<commit_message>
docs: update presentation link and remove redundant slide deck file
</commit_message>
<xml_diff>
--- a/Sovereign_Swarm.pptx
+++ b/Sovereign_Swarm.pptx
@@ -3142,7 +3142,7 @@
           <a:p>
             <a:pPr algn="ctr">
               <a:spcAft>
-                <a:spcPts val="3000"/>
+                <a:spcPts val="1000"/>
               </a:spcAft>
               <a:defRPr sz="2400">
                 <a:solidFill>
@@ -3153,6 +3153,22 @@
             </a:pPr>
             <a:r>
               <a:t>Multi-Tone Video Captioning Powered by Multimodal AI</a:t>
+            </a:r>
+          </a:p>
+          <a:p>
+            <a:pPr algn="ctr">
+              <a:spcAft>
+                <a:spcPts val="2500"/>
+              </a:spcAft>
+              <a:defRPr sz="2000">
+                <a:solidFill>
+                  <a:srgbClr val="9CA3AF"/>
+                </a:solidFill>
+                <a:latin typeface="Inter"/>
+              </a:defRPr>
+            </a:pPr>
+            <a:r>
+              <a:t>by Harsh Verma</a:t>
             </a:r>
           </a:p>
           <a:p>

</xml_diff>